<commit_message>
Repair prototype deck for web viewer
</commit_message>
<xml_diff>
--- a/GovAssist_UCS503_Prototype_Pitch_Final_Rev3.pptx
+++ b/GovAssist_UCS503_Prototype_Pitch_Final_Rev3.pptx
@@ -5432,9 +5432,9 @@
           <p:nvPr/>
         </p:nvSpPr>
         <p:spPr>
-          <a:xfrm>
-            <a:off x="5440680" y="3931920"/>
-            <a:ext cx="0" cy="-1188720"/>
+          <a:xfrm flipV="1">
+            <a:off x="5440680" y="2743200"/>
+            <a:ext cx="0" cy="1188720"/>
           </a:xfrm>
           <a:prstGeom prst="line">
             <a:avLst/>
@@ -5482,9 +5482,9 @@
           <p:nvPr/>
         </p:nvSpPr>
         <p:spPr>
-          <a:xfrm>
-            <a:off x="9372600" y="3931920"/>
-            <a:ext cx="0" cy="-1188720"/>
+          <a:xfrm flipV="1">
+            <a:off x="9372600" y="2743200"/>
+            <a:ext cx="0" cy="1188720"/>
           </a:xfrm>
           <a:prstGeom prst="line">
             <a:avLst/>
@@ -16122,9 +16122,9 @@
           <p:nvPr/>
         </p:nvSpPr>
         <p:spPr>
-          <a:xfrm>
-            <a:off x="9601200" y="2331720"/>
-            <a:ext cx="0" cy="-283464"/>
+          <a:xfrm flipV="1">
+            <a:off x="9601200" y="2048256"/>
+            <a:ext cx="0" cy="283464"/>
           </a:xfrm>
           <a:prstGeom prst="line">
             <a:avLst/>
@@ -16342,9 +16342,9 @@
           <p:nvPr/>
         </p:nvSpPr>
         <p:spPr>
-          <a:xfrm>
-            <a:off x="8869680" y="4041648"/>
-            <a:ext cx="-411480" cy="667512"/>
+          <a:xfrm flipH="1">
+            <a:off x="8458200" y="4041648"/>
+            <a:ext cx="411480" cy="667512"/>
           </a:xfrm>
           <a:prstGeom prst="line">
             <a:avLst/>

</xml_diff>